<commit_message>
Plotting cliques over the temperature graph, not a lot of new info
</commit_message>
<xml_diff>
--- a/figures.pptx
+++ b/figures.pptx
@@ -104,6 +104,11 @@
       </a:defRPr>
     </a:lvl9pPr>
   </p:defaultTextStyle>
+  <p:extLst>
+    <p:ext uri="{EFAFB233-063F-42B5-8137-9DF3F51BA10A}">
+      <p15:sldGuideLst xmlns:p15="http://schemas.microsoft.com/office/powerpoint/2012/main"/>
+    </p:ext>
+  </p:extLst>
 </p:presentation>
 </file>
 
@@ -254,7 +259,7 @@
           <a:p>
             <a:fld id="{8C8D10EE-798B-4FEB-8AE2-A25F1C971DC0}" type="datetimeFigureOut">
               <a:rPr lang="en-US" smtClean="0"/>
-              <a:t>4/27/2026</a:t>
+              <a:t>4/28/2026</a:t>
             </a:fld>
             <a:endParaRPr lang="en-US"/>
           </a:p>
@@ -452,7 +457,7 @@
           <a:p>
             <a:fld id="{8C8D10EE-798B-4FEB-8AE2-A25F1C971DC0}" type="datetimeFigureOut">
               <a:rPr lang="en-US" smtClean="0"/>
-              <a:t>4/27/2026</a:t>
+              <a:t>4/28/2026</a:t>
             </a:fld>
             <a:endParaRPr lang="en-US"/>
           </a:p>
@@ -660,7 +665,7 @@
           <a:p>
             <a:fld id="{8C8D10EE-798B-4FEB-8AE2-A25F1C971DC0}" type="datetimeFigureOut">
               <a:rPr lang="en-US" smtClean="0"/>
-              <a:t>4/27/2026</a:t>
+              <a:t>4/28/2026</a:t>
             </a:fld>
             <a:endParaRPr lang="en-US"/>
           </a:p>
@@ -858,7 +863,7 @@
           <a:p>
             <a:fld id="{8C8D10EE-798B-4FEB-8AE2-A25F1C971DC0}" type="datetimeFigureOut">
               <a:rPr lang="en-US" smtClean="0"/>
-              <a:t>4/27/2026</a:t>
+              <a:t>4/28/2026</a:t>
             </a:fld>
             <a:endParaRPr lang="en-US"/>
           </a:p>
@@ -1133,7 +1138,7 @@
           <a:p>
             <a:fld id="{8C8D10EE-798B-4FEB-8AE2-A25F1C971DC0}" type="datetimeFigureOut">
               <a:rPr lang="en-US" smtClean="0"/>
-              <a:t>4/27/2026</a:t>
+              <a:t>4/28/2026</a:t>
             </a:fld>
             <a:endParaRPr lang="en-US"/>
           </a:p>
@@ -1398,7 +1403,7 @@
           <a:p>
             <a:fld id="{8C8D10EE-798B-4FEB-8AE2-A25F1C971DC0}" type="datetimeFigureOut">
               <a:rPr lang="en-US" smtClean="0"/>
-              <a:t>4/27/2026</a:t>
+              <a:t>4/28/2026</a:t>
             </a:fld>
             <a:endParaRPr lang="en-US"/>
           </a:p>
@@ -1810,7 +1815,7 @@
           <a:p>
             <a:fld id="{8C8D10EE-798B-4FEB-8AE2-A25F1C971DC0}" type="datetimeFigureOut">
               <a:rPr lang="en-US" smtClean="0"/>
-              <a:t>4/27/2026</a:t>
+              <a:t>4/28/2026</a:t>
             </a:fld>
             <a:endParaRPr lang="en-US"/>
           </a:p>
@@ -1951,7 +1956,7 @@
           <a:p>
             <a:fld id="{8C8D10EE-798B-4FEB-8AE2-A25F1C971DC0}" type="datetimeFigureOut">
               <a:rPr lang="en-US" smtClean="0"/>
-              <a:t>4/27/2026</a:t>
+              <a:t>4/28/2026</a:t>
             </a:fld>
             <a:endParaRPr lang="en-US"/>
           </a:p>
@@ -2064,7 +2069,7 @@
           <a:p>
             <a:fld id="{8C8D10EE-798B-4FEB-8AE2-A25F1C971DC0}" type="datetimeFigureOut">
               <a:rPr lang="en-US" smtClean="0"/>
-              <a:t>4/27/2026</a:t>
+              <a:t>4/28/2026</a:t>
             </a:fld>
             <a:endParaRPr lang="en-US"/>
           </a:p>
@@ -2375,7 +2380,7 @@
           <a:p>
             <a:fld id="{8C8D10EE-798B-4FEB-8AE2-A25F1C971DC0}" type="datetimeFigureOut">
               <a:rPr lang="en-US" smtClean="0"/>
-              <a:t>4/27/2026</a:t>
+              <a:t>4/28/2026</a:t>
             </a:fld>
             <a:endParaRPr lang="en-US"/>
           </a:p>
@@ -2663,7 +2668,7 @@
           <a:p>
             <a:fld id="{8C8D10EE-798B-4FEB-8AE2-A25F1C971DC0}" type="datetimeFigureOut">
               <a:rPr lang="en-US" smtClean="0"/>
-              <a:t>4/27/2026</a:t>
+              <a:t>4/28/2026</a:t>
             </a:fld>
             <a:endParaRPr lang="en-US"/>
           </a:p>
@@ -2904,7 +2909,7 @@
           <a:p>
             <a:fld id="{8C8D10EE-798B-4FEB-8AE2-A25F1C971DC0}" type="datetimeFigureOut">
               <a:rPr lang="en-US" smtClean="0"/>
-              <a:t>4/27/2026</a:t>
+              <a:t>4/28/2026</a:t>
             </a:fld>
             <a:endParaRPr lang="en-US"/>
           </a:p>
@@ -3321,200 +3326,262 @@
           <a:chExt cx="0" cy="0"/>
         </a:xfrm>
       </p:grpSpPr>
-      <p:pic>
-        <p:nvPicPr>
-          <p:cNvPr id="5" name="Picture 4">
-            <a:extLst>
-              <a:ext uri="{FF2B5EF4-FFF2-40B4-BE49-F238E27FC236}">
-                <a16:creationId xmlns:a16="http://schemas.microsoft.com/office/drawing/2014/main" id="{BD4FB369-6B25-70F3-E72E-3BA9AE8EFB77}"/>
-              </a:ext>
-            </a:extLst>
-          </p:cNvPr>
-          <p:cNvPicPr>
-            <a:picLocks noChangeAspect="1"/>
-          </p:cNvPicPr>
+      <p:grpSp>
+        <p:nvGrpSpPr>
+          <p:cNvPr id="16" name="Group 15">
+            <a:extLst>
+              <a:ext uri="{FF2B5EF4-FFF2-40B4-BE49-F238E27FC236}">
+                <a16:creationId xmlns:a16="http://schemas.microsoft.com/office/drawing/2014/main" id="{D552593A-788B-AD1B-CD78-370E40570124}"/>
+              </a:ext>
+            </a:extLst>
+          </p:cNvPr>
+          <p:cNvGrpSpPr/>
           <p:nvPr/>
-        </p:nvPicPr>
-        <p:blipFill>
-          <a:blip r:embed="rId2"/>
-          <a:stretch>
-            <a:fillRect/>
-          </a:stretch>
-        </p:blipFill>
-        <p:spPr>
+        </p:nvGrpSpPr>
+        <p:grpSpPr>
           <a:xfrm>
-            <a:off x="1269711" y="1054924"/>
-            <a:ext cx="9107666" cy="5765861"/>
+            <a:off x="1217741" y="412655"/>
+            <a:ext cx="9462663" cy="7116793"/>
+            <a:chOff x="1217741" y="412655"/>
+            <a:chExt cx="9462663" cy="7116793"/>
           </a:xfrm>
-          <a:prstGeom prst="rect">
-            <a:avLst/>
-          </a:prstGeom>
-        </p:spPr>
-      </p:pic>
-      <p:sp>
-        <p:nvSpPr>
-          <p:cNvPr id="6" name="TextBox 5">
-            <a:extLst>
-              <a:ext uri="{FF2B5EF4-FFF2-40B4-BE49-F238E27FC236}">
-                <a16:creationId xmlns:a16="http://schemas.microsoft.com/office/drawing/2014/main" id="{32A4BC37-390A-D671-7ED4-515AF3654B3C}"/>
-              </a:ext>
-            </a:extLst>
-          </p:cNvPr>
-          <p:cNvSpPr txBox="1"/>
-          <p:nvPr/>
-        </p:nvSpPr>
-        <p:spPr>
-          <a:xfrm>
-            <a:off x="1731336" y="685589"/>
-            <a:ext cx="2617380" cy="369332"/>
-          </a:xfrm>
-          <a:prstGeom prst="rect">
-            <a:avLst/>
-          </a:prstGeom>
-          <a:solidFill>
-            <a:schemeClr val="bg2"/>
-          </a:solidFill>
-        </p:spPr>
-        <p:txBody>
-          <a:bodyPr wrap="square" rtlCol="0">
-            <a:spAutoFit/>
-          </a:bodyPr>
-          <a:lstStyle/>
-          <a:p>
-            <a:pPr algn="ctr"/>
-            <a:r>
-              <a:rPr lang="en-US" dirty="0">
-                <a:latin typeface="Arial" panose="020B0604020202020204" pitchFamily="34" charset="0"/>
-                <a:cs typeface="Arial" panose="020B0604020202020204" pitchFamily="34" charset="0"/>
-              </a:rPr>
-              <a:t>Summer</a:t>
-            </a:r>
-          </a:p>
-        </p:txBody>
-      </p:sp>
-      <p:sp>
-        <p:nvSpPr>
-          <p:cNvPr id="7" name="TextBox 6">
-            <a:extLst>
-              <a:ext uri="{FF2B5EF4-FFF2-40B4-BE49-F238E27FC236}">
-                <a16:creationId xmlns:a16="http://schemas.microsoft.com/office/drawing/2014/main" id="{9C36012C-E3E4-2C5F-C866-0EEAC867723F}"/>
-              </a:ext>
-            </a:extLst>
-          </p:cNvPr>
-          <p:cNvSpPr txBox="1"/>
-          <p:nvPr/>
-        </p:nvSpPr>
-        <p:spPr>
-          <a:xfrm>
-            <a:off x="4396564" y="685589"/>
-            <a:ext cx="1068572" cy="369332"/>
-          </a:xfrm>
-          <a:prstGeom prst="rect">
-            <a:avLst/>
-          </a:prstGeom>
-          <a:solidFill>
-            <a:schemeClr val="bg2"/>
-          </a:solidFill>
-        </p:spPr>
-        <p:txBody>
-          <a:bodyPr wrap="square" rtlCol="0">
-            <a:spAutoFit/>
-          </a:bodyPr>
-          <a:lstStyle/>
-          <a:p>
-            <a:pPr algn="ctr"/>
-            <a:r>
-              <a:rPr lang="en-US" dirty="0">
-                <a:latin typeface="Arial" panose="020B0604020202020204" pitchFamily="34" charset="0"/>
-                <a:cs typeface="Arial" panose="020B0604020202020204" pitchFamily="34" charset="0"/>
-              </a:rPr>
-              <a:t>Fall</a:t>
-            </a:r>
-          </a:p>
-        </p:txBody>
-      </p:sp>
-      <p:sp>
-        <p:nvSpPr>
-          <p:cNvPr id="8" name="TextBox 7">
-            <a:extLst>
-              <a:ext uri="{FF2B5EF4-FFF2-40B4-BE49-F238E27FC236}">
-                <a16:creationId xmlns:a16="http://schemas.microsoft.com/office/drawing/2014/main" id="{4D0CC35F-3309-6F45-B7C2-E9EE131BBF31}"/>
-              </a:ext>
-            </a:extLst>
-          </p:cNvPr>
-          <p:cNvSpPr txBox="1"/>
-          <p:nvPr/>
-        </p:nvSpPr>
-        <p:spPr>
-          <a:xfrm>
-            <a:off x="5512982" y="685590"/>
-            <a:ext cx="2057400" cy="369332"/>
-          </a:xfrm>
-          <a:prstGeom prst="rect">
-            <a:avLst/>
-          </a:prstGeom>
-          <a:solidFill>
-            <a:schemeClr val="bg2"/>
-          </a:solidFill>
-        </p:spPr>
-        <p:txBody>
-          <a:bodyPr wrap="square" rtlCol="0">
-            <a:spAutoFit/>
-          </a:bodyPr>
-          <a:lstStyle/>
-          <a:p>
-            <a:pPr algn="ctr"/>
-            <a:r>
-              <a:rPr lang="en-US" dirty="0">
-                <a:latin typeface="Arial" panose="020B0604020202020204" pitchFamily="34" charset="0"/>
-                <a:cs typeface="Arial" panose="020B0604020202020204" pitchFamily="34" charset="0"/>
-              </a:rPr>
-              <a:t>Winter</a:t>
-            </a:r>
-          </a:p>
-        </p:txBody>
-      </p:sp>
-      <p:sp>
-        <p:nvSpPr>
-          <p:cNvPr id="9" name="TextBox 8">
-            <a:extLst>
-              <a:ext uri="{FF2B5EF4-FFF2-40B4-BE49-F238E27FC236}">
-                <a16:creationId xmlns:a16="http://schemas.microsoft.com/office/drawing/2014/main" id="{5C161179-74F8-1910-2B5F-7F1B2FF75377}"/>
-              </a:ext>
-            </a:extLst>
-          </p:cNvPr>
-          <p:cNvSpPr txBox="1"/>
-          <p:nvPr/>
-        </p:nvSpPr>
-        <p:spPr>
-          <a:xfrm>
-            <a:off x="7618230" y="685590"/>
-            <a:ext cx="1313120" cy="369332"/>
-          </a:xfrm>
-          <a:prstGeom prst="rect">
-            <a:avLst/>
-          </a:prstGeom>
-          <a:solidFill>
-            <a:schemeClr val="bg2"/>
-          </a:solidFill>
-        </p:spPr>
-        <p:txBody>
-          <a:bodyPr wrap="square" rtlCol="0">
-            <a:spAutoFit/>
-          </a:bodyPr>
-          <a:lstStyle/>
-          <a:p>
-            <a:pPr algn="ctr"/>
-            <a:r>
-              <a:rPr lang="en-US" dirty="0">
-                <a:latin typeface="Arial" panose="020B0604020202020204" pitchFamily="34" charset="0"/>
-                <a:cs typeface="Arial" panose="020B0604020202020204" pitchFamily="34" charset="0"/>
-              </a:rPr>
-              <a:t>Spring</a:t>
-            </a:r>
-          </a:p>
-        </p:txBody>
-      </p:sp>
+        </p:grpSpPr>
+        <p:pic>
+          <p:nvPicPr>
+            <p:cNvPr id="15" name="Picture 14">
+              <a:extLst>
+                <a:ext uri="{FF2B5EF4-FFF2-40B4-BE49-F238E27FC236}">
+                  <a16:creationId xmlns:a16="http://schemas.microsoft.com/office/drawing/2014/main" id="{5B35717F-A786-2302-B44E-E8E86673F0D9}"/>
+                </a:ext>
+              </a:extLst>
+            </p:cNvPr>
+            <p:cNvPicPr>
+              <a:picLocks noChangeAspect="1"/>
+            </p:cNvPicPr>
+            <p:nvPr/>
+          </p:nvPicPr>
+          <p:blipFill>
+            <a:blip r:embed="rId2"/>
+            <a:stretch>
+              <a:fillRect/>
+            </a:stretch>
+          </p:blipFill>
+          <p:spPr>
+            <a:xfrm>
+              <a:off x="1217741" y="412655"/>
+              <a:ext cx="9462663" cy="7116793"/>
+            </a:xfrm>
+            <a:prstGeom prst="rect">
+              <a:avLst/>
+            </a:prstGeom>
+          </p:spPr>
+        </p:pic>
+        <p:sp>
+          <p:nvSpPr>
+            <p:cNvPr id="6" name="TextBox 5">
+              <a:extLst>
+                <a:ext uri="{FF2B5EF4-FFF2-40B4-BE49-F238E27FC236}">
+                  <a16:creationId xmlns:a16="http://schemas.microsoft.com/office/drawing/2014/main" id="{32A4BC37-390A-D671-7ED4-515AF3654B3C}"/>
+                </a:ext>
+              </a:extLst>
+            </p:cNvPr>
+            <p:cNvSpPr txBox="1"/>
+            <p:nvPr/>
+          </p:nvSpPr>
+          <p:spPr>
+            <a:xfrm>
+              <a:off x="1950193" y="1014507"/>
+              <a:ext cx="2292198" cy="369332"/>
+            </a:xfrm>
+            <a:prstGeom prst="rect">
+              <a:avLst/>
+            </a:prstGeom>
+            <a:solidFill>
+              <a:schemeClr val="bg2"/>
+            </a:solidFill>
+          </p:spPr>
+          <p:txBody>
+            <a:bodyPr wrap="square" rtlCol="0">
+              <a:spAutoFit/>
+            </a:bodyPr>
+            <a:lstStyle/>
+            <a:p>
+              <a:pPr algn="ctr"/>
+              <a:r>
+                <a:rPr lang="en-US" dirty="0">
+                  <a:latin typeface="Arial" panose="020B0604020202020204" pitchFamily="34" charset="0"/>
+                  <a:cs typeface="Arial" panose="020B0604020202020204" pitchFamily="34" charset="0"/>
+                </a:rPr>
+                <a:t>Summer</a:t>
+              </a:r>
+            </a:p>
+          </p:txBody>
+        </p:sp>
+        <p:sp>
+          <p:nvSpPr>
+            <p:cNvPr id="7" name="TextBox 6">
+              <a:extLst>
+                <a:ext uri="{FF2B5EF4-FFF2-40B4-BE49-F238E27FC236}">
+                  <a16:creationId xmlns:a16="http://schemas.microsoft.com/office/drawing/2014/main" id="{9C36012C-E3E4-2C5F-C866-0EEAC867723F}"/>
+                </a:ext>
+              </a:extLst>
+            </p:cNvPr>
+            <p:cNvSpPr txBox="1"/>
+            <p:nvPr/>
+          </p:nvSpPr>
+          <p:spPr>
+            <a:xfrm>
+              <a:off x="4273848" y="1014507"/>
+              <a:ext cx="1158283" cy="369332"/>
+            </a:xfrm>
+            <a:prstGeom prst="rect">
+              <a:avLst/>
+            </a:prstGeom>
+            <a:solidFill>
+              <a:schemeClr val="bg2"/>
+            </a:solidFill>
+          </p:spPr>
+          <p:txBody>
+            <a:bodyPr wrap="square" rtlCol="0">
+              <a:spAutoFit/>
+            </a:bodyPr>
+            <a:lstStyle/>
+            <a:p>
+              <a:pPr algn="ctr"/>
+              <a:r>
+                <a:rPr lang="en-US" dirty="0">
+                  <a:latin typeface="Arial" panose="020B0604020202020204" pitchFamily="34" charset="0"/>
+                  <a:cs typeface="Arial" panose="020B0604020202020204" pitchFamily="34" charset="0"/>
+                </a:rPr>
+                <a:t>Fall</a:t>
+              </a:r>
+            </a:p>
+          </p:txBody>
+        </p:sp>
+        <p:sp>
+          <p:nvSpPr>
+            <p:cNvPr id="8" name="TextBox 7">
+              <a:extLst>
+                <a:ext uri="{FF2B5EF4-FFF2-40B4-BE49-F238E27FC236}">
+                  <a16:creationId xmlns:a16="http://schemas.microsoft.com/office/drawing/2014/main" id="{4D0CC35F-3309-6F45-B7C2-E9EE131BBF31}"/>
+                </a:ext>
+              </a:extLst>
+            </p:cNvPr>
+            <p:cNvSpPr txBox="1"/>
+            <p:nvPr/>
+          </p:nvSpPr>
+          <p:spPr>
+            <a:xfrm>
+              <a:off x="5463590" y="1014507"/>
+              <a:ext cx="1392638" cy="369332"/>
+            </a:xfrm>
+            <a:prstGeom prst="rect">
+              <a:avLst/>
+            </a:prstGeom>
+            <a:solidFill>
+              <a:schemeClr val="bg2"/>
+            </a:solidFill>
+          </p:spPr>
+          <p:txBody>
+            <a:bodyPr wrap="square" rtlCol="0">
+              <a:spAutoFit/>
+            </a:bodyPr>
+            <a:lstStyle/>
+            <a:p>
+              <a:pPr algn="ctr"/>
+              <a:r>
+                <a:rPr lang="en-US" dirty="0">
+                  <a:latin typeface="Arial" panose="020B0604020202020204" pitchFamily="34" charset="0"/>
+                  <a:cs typeface="Arial" panose="020B0604020202020204" pitchFamily="34" charset="0"/>
+                </a:rPr>
+                <a:t>Winter</a:t>
+              </a:r>
+            </a:p>
+          </p:txBody>
+        </p:sp>
+        <p:sp>
+          <p:nvSpPr>
+            <p:cNvPr id="9" name="TextBox 8">
+              <a:extLst>
+                <a:ext uri="{FF2B5EF4-FFF2-40B4-BE49-F238E27FC236}">
+                  <a16:creationId xmlns:a16="http://schemas.microsoft.com/office/drawing/2014/main" id="{5C161179-74F8-1910-2B5F-7F1B2FF75377}"/>
+                </a:ext>
+              </a:extLst>
+            </p:cNvPr>
+            <p:cNvSpPr txBox="1"/>
+            <p:nvPr/>
+          </p:nvSpPr>
+          <p:spPr>
+            <a:xfrm>
+              <a:off x="6887685" y="1014507"/>
+              <a:ext cx="922372" cy="369332"/>
+            </a:xfrm>
+            <a:prstGeom prst="rect">
+              <a:avLst/>
+            </a:prstGeom>
+            <a:solidFill>
+              <a:schemeClr val="bg2"/>
+            </a:solidFill>
+          </p:spPr>
+          <p:txBody>
+            <a:bodyPr wrap="square" rtlCol="0">
+              <a:spAutoFit/>
+            </a:bodyPr>
+            <a:lstStyle/>
+            <a:p>
+              <a:pPr algn="ctr"/>
+              <a:r>
+                <a:rPr lang="en-US" dirty="0">
+                  <a:latin typeface="Arial" panose="020B0604020202020204" pitchFamily="34" charset="0"/>
+                  <a:cs typeface="Arial" panose="020B0604020202020204" pitchFamily="34" charset="0"/>
+                </a:rPr>
+                <a:t>Spring</a:t>
+              </a:r>
+            </a:p>
+          </p:txBody>
+        </p:sp>
+        <p:sp>
+          <p:nvSpPr>
+            <p:cNvPr id="11" name="TextBox 10">
+              <a:extLst>
+                <a:ext uri="{FF2B5EF4-FFF2-40B4-BE49-F238E27FC236}">
+                  <a16:creationId xmlns:a16="http://schemas.microsoft.com/office/drawing/2014/main" id="{9D3CCAE0-D2FB-FB36-C0EE-FDAFA91DF179}"/>
+                </a:ext>
+              </a:extLst>
+            </p:cNvPr>
+            <p:cNvSpPr txBox="1"/>
+            <p:nvPr/>
+          </p:nvSpPr>
+          <p:spPr>
+            <a:xfrm>
+              <a:off x="7841515" y="1014507"/>
+              <a:ext cx="664530" cy="369332"/>
+            </a:xfrm>
+            <a:prstGeom prst="rect">
+              <a:avLst/>
+            </a:prstGeom>
+            <a:solidFill>
+              <a:schemeClr val="bg2"/>
+            </a:solidFill>
+          </p:spPr>
+          <p:txBody>
+            <a:bodyPr wrap="square" rtlCol="0">
+              <a:spAutoFit/>
+            </a:bodyPr>
+            <a:lstStyle/>
+            <a:p>
+              <a:pPr algn="ctr"/>
+              <a:r>
+                <a:rPr lang="en-US" dirty="0">
+                  <a:latin typeface="Arial" panose="020B0604020202020204" pitchFamily="34" charset="0"/>
+                  <a:cs typeface="Arial" panose="020B0604020202020204" pitchFamily="34" charset="0"/>
+                </a:rPr>
+                <a:t>Sum</a:t>
+              </a:r>
+            </a:p>
+          </p:txBody>
+        </p:sp>
+      </p:grpSp>
     </p:spTree>
     <p:extLst>
       <p:ext uri="{BB962C8B-B14F-4D97-AF65-F5344CB8AC3E}">

</xml_diff>